<commit_message>
Dodat slajd sa primerom clanka u tri oblika
</commit_message>
<xml_diff>
--- a/prezentacija.pptx
+++ b/prezentacija.pptx
@@ -21,6 +21,7 @@
     <p:sldId id="269" r:id="rId21"/>
     <p:sldId id="270" r:id="rId22"/>
     <p:sldId id="271" r:id="rId23"/>
+    <p:sldId id="272" r:id="rId24"/>
   </p:sldIdLst>
   <p:sldSz cx="12191695" cy="6858000" type="screen4x3"/>
   <p:notesSz cx="6858000" cy="9144000"/>
@@ -587,7 +588,7 @@
           <a:lstStyle/>
           <a:p>
             <a:r>
-              <a:t>Dotreniranje naspram zamrznutih embedinga</a:t>
+              <a:t>CNN, BiLSTM i njihov hibrid</a:t>
             </a:r>
           </a:p>
         </p:txBody>
@@ -657,7 +658,7 @@
           <a:lstStyle/>
           <a:p>
             <a:r>
-              <a:t>Metrike evaluacije</a:t>
+              <a:t>Dotreniranje naspram zamrznutih embedinga</a:t>
             </a:r>
           </a:p>
         </p:txBody>
@@ -727,7 +728,7 @@
           <a:lstStyle/>
           <a:p>
             <a:r>
-              <a:t>Svih trinaest modela na istom test skupu od 9 629 članaka</a:t>
+              <a:t>Metrike evaluacije</a:t>
             </a:r>
           </a:p>
         </p:txBody>
@@ -797,7 +798,7 @@
           <a:lstStyle/>
           <a:p>
             <a:r>
-              <a:t>Tačnost i složenost modela</a:t>
+              <a:t>Svih trinaest modela na istom test skupu od 9 629 članaka</a:t>
             </a:r>
           </a:p>
         </p:txBody>
@@ -867,7 +868,7 @@
           <a:lstStyle/>
           <a:p>
             <a:r>
-              <a:t>Preciznost i odziv po modelu</a:t>
+              <a:t>Tačnost i složenost modela</a:t>
             </a:r>
           </a:p>
         </p:txBody>
@@ -937,7 +938,7 @@
           <a:lstStyle/>
           <a:p>
             <a:r>
-              <a:t>Preprilagođavanje i generalizacija</a:t>
+              <a:t>Preciznost i odziv po modelu</a:t>
             </a:r>
           </a:p>
         </p:txBody>
@@ -1007,6 +1008,76 @@
           <a:lstStyle/>
           <a:p>
             <a:r>
+              <a:t>Preprilagođavanje i generalizacija</a:t>
+            </a:r>
+          </a:p>
+        </p:txBody>
+      </p:sp>
+      <p:sp>
+        <p:nvSpPr>
+          <p:cNvPr id="4" name="Slide Number Placeholder 3"/>
+          <p:cNvSpPr>
+            <a:spLocks noGrp="1"/>
+          </p:cNvSpPr>
+          <p:nvPr>
+            <p:ph type="sldNum" idx="5" sz="quarter"/>
+          </p:nvPr>
+        </p:nvSpPr>
+        <p:spPr/>
+      </p:sp>
+    </p:spTree>
+  </p:cSld>
+  <p:clrMapOvr>
+    <a:masterClrMapping/>
+  </p:clrMapOvr>
+</p:notes>
+</file>
+
+<file path=ppt/notesSlides/notesSlide17.xml><?xml version="1.0" encoding="utf-8"?>
+<p:notes xmlns:a="http://schemas.openxmlformats.org/drawingml/2006/main" xmlns:p="http://schemas.openxmlformats.org/presentationml/2006/main" xmlns:r="http://schemas.openxmlformats.org/officeDocument/2006/relationships">
+  <p:cSld>
+    <p:spTree>
+      <p:nvGrpSpPr>
+        <p:cNvPr id="1" name=""/>
+        <p:cNvGrpSpPr/>
+        <p:nvPr/>
+      </p:nvGrpSpPr>
+      <p:grpSpPr>
+        <a:xfrm>
+          <a:off x="0" y="0"/>
+          <a:ext cx="0" cy="0"/>
+          <a:chOff x="0" y="0"/>
+          <a:chExt cx="0" cy="0"/>
+        </a:xfrm>
+      </p:grpSpPr>
+      <p:sp>
+        <p:nvSpPr>
+          <p:cNvPr id="2" name="Slide Image Placeholder 1"/>
+          <p:cNvSpPr>
+            <a:spLocks noGrp="1"/>
+          </p:cNvSpPr>
+          <p:nvPr>
+            <p:ph type="sldImg" idx="2"/>
+          </p:nvPr>
+        </p:nvSpPr>
+        <p:spPr/>
+      </p:sp>
+      <p:sp>
+        <p:nvSpPr>
+          <p:cNvPr id="3" name="Notes Placeholder 2"/>
+          <p:cNvSpPr>
+            <a:spLocks noGrp="1"/>
+          </p:cNvSpPr>
+          <p:nvPr>
+            <p:ph type="body" idx="3" sz="quarter"/>
+          </p:nvPr>
+        </p:nvSpPr>
+        <p:spPr/>
+        <p:txBody>
+          <a:bodyPr/>
+          <a:lstStyle/>
+          <a:p>
+            <a:r>
               <a:t>Zaključci</a:t>
             </a:r>
           </a:p>
@@ -1357,7 +1428,7 @@
           <a:lstStyle/>
           <a:p>
             <a:r>
-              <a:t>Kako tekst pretvaramo u brojeve</a:t>
+              <a:t>Isti članak u tri oblika</a:t>
             </a:r>
           </a:p>
         </p:txBody>
@@ -1427,7 +1498,7 @@
           <a:lstStyle/>
           <a:p>
             <a:r>
-              <a:t>Tri porodice modela, tri vrste ulaza</a:t>
+              <a:t>Kako tekst pretvaramo u brojeve</a:t>
             </a:r>
           </a:p>
         </p:txBody>
@@ -1497,7 +1568,7 @@
           <a:lstStyle/>
           <a:p>
             <a:r>
-              <a:t>Četiri algoritma nad TF-IDF vektorima</a:t>
+              <a:t>Tri porodice modela, tri vrste ulaza</a:t>
             </a:r>
           </a:p>
         </p:txBody>
@@ -1567,7 +1638,7 @@
           <a:lstStyle/>
           <a:p>
             <a:r>
-              <a:t>CNN, BiLSTM i njihov hibrid</a:t>
+              <a:t>Četiri algoritma nad TF-IDF vektorima</a:t>
             </a:r>
           </a:p>
         </p:txBody>
@@ -4870,6 +4941,48 @@
       <p:pic>
         <p:nvPicPr>
           <p:cNvPr id="2" name="Picture 1" descr="pptx_16.png"/>
+          <p:cNvPicPr>
+            <a:picLocks noChangeAspect="1"/>
+          </p:cNvPicPr>
+          <p:nvPr/>
+        </p:nvPicPr>
+        <p:blipFill>
+          <a:blip r:embed="rId2"/>
+          <a:stretch>
+            <a:fillRect/>
+          </a:stretch>
+        </p:blipFill>
+        <p:spPr>
+          <a:xfrm>
+            <a:off x="0" y="0"/>
+            <a:ext cx="12191695" cy="6858000"/>
+          </a:xfrm>
+          <a:prstGeom prst="rect">
+            <a:avLst/>
+          </a:prstGeom>
+        </p:spPr>
+      </p:pic>
+    </p:spTree>
+  </p:cSld>
+  <p:clrMapOvr>
+    <a:masterClrMapping/>
+  </p:clrMapOvr>
+</p:sld>
+</file>
+
+<file path=ppt/slides/slide17.xml><?xml version="1.0" encoding="utf-8"?>
+<p:sld xmlns:a="http://schemas.openxmlformats.org/drawingml/2006/main" xmlns:p="http://schemas.openxmlformats.org/presentationml/2006/main" xmlns:r="http://schemas.openxmlformats.org/officeDocument/2006/relationships">
+  <p:cSld>
+    <p:spTree>
+      <p:nvGrpSpPr>
+        <p:cNvPr id="1" name=""/>
+        <p:cNvGrpSpPr/>
+        <p:nvPr/>
+      </p:nvGrpSpPr>
+      <p:grpSpPr/>
+      <p:pic>
+        <p:nvPicPr>
+          <p:cNvPr id="2" name="Picture 1" descr="pptx_17.png"/>
           <p:cNvPicPr>
             <a:picLocks noChangeAspect="1"/>
           </p:cNvPicPr>

</xml_diff>

<commit_message>
Poredjenje mreza i opis transformera, metrike pre modela
</commit_message>
<xml_diff>
--- a/prezentacija.pptx
+++ b/prezentacija.pptx
@@ -588,7 +588,7 @@
           <a:lstStyle/>
           <a:p>
             <a:r>
-              <a:t>CNN, BiLSTM i njihov hibrid</a:t>
+              <a:t>Četiri algoritma nad TF-IDF vektorima</a:t>
             </a:r>
           </a:p>
         </p:txBody>
@@ -658,7 +658,7 @@
           <a:lstStyle/>
           <a:p>
             <a:r>
-              <a:t>Dotreniranje naspram zamrznutih embedinga</a:t>
+              <a:t>CNN, BiLSTM i hibrid: ista osnova, različita sredina</a:t>
             </a:r>
           </a:p>
         </p:txBody>
@@ -728,7 +728,7 @@
           <a:lstStyle/>
           <a:p>
             <a:r>
-              <a:t>Metrike evaluacije</a:t>
+              <a:t>DistilBERT i MiniLM: šta su i šta smo menjali</a:t>
             </a:r>
           </a:p>
         </p:txBody>
@@ -1638,7 +1638,7 @@
           <a:lstStyle/>
           <a:p>
             <a:r>
-              <a:t>Četiri algoritma nad TF-IDF vektorima</a:t>
+              <a:t>Metrike evaluacije</a:t>
             </a:r>
           </a:p>
         </p:txBody>

</xml_diff>

<commit_message>
Tabela treniranja i provere za sve modele, krive za sve tri mreze
</commit_message>
<xml_diff>
--- a/prezentacija.pptx
+++ b/prezentacija.pptx
@@ -22,6 +22,7 @@
     <p:sldId id="270" r:id="rId22"/>
     <p:sldId id="271" r:id="rId23"/>
     <p:sldId id="272" r:id="rId24"/>
+    <p:sldId id="273" r:id="rId25"/>
   </p:sldIdLst>
   <p:sldSz cx="12191695" cy="6858000" type="screen4x3"/>
   <p:notesSz cx="6858000" cy="9144000"/>
@@ -1008,7 +1009,7 @@
           <a:lstStyle/>
           <a:p>
             <a:r>
-              <a:t>Preprilagođavanje i generalizacija</a:t>
+              <a:t>Kako je koji model treniran i proveren</a:t>
             </a:r>
           </a:p>
         </p:txBody>
@@ -1034,6 +1035,76 @@
 </file>
 
 <file path=ppt/notesSlides/notesSlide17.xml><?xml version="1.0" encoding="utf-8"?>
+<p:notes xmlns:a="http://schemas.openxmlformats.org/drawingml/2006/main" xmlns:p="http://schemas.openxmlformats.org/presentationml/2006/main" xmlns:r="http://schemas.openxmlformats.org/officeDocument/2006/relationships">
+  <p:cSld>
+    <p:spTree>
+      <p:nvGrpSpPr>
+        <p:cNvPr id="1" name=""/>
+        <p:cNvGrpSpPr/>
+        <p:nvPr/>
+      </p:nvGrpSpPr>
+      <p:grpSpPr>
+        <a:xfrm>
+          <a:off x="0" y="0"/>
+          <a:ext cx="0" cy="0"/>
+          <a:chOff x="0" y="0"/>
+          <a:chExt cx="0" cy="0"/>
+        </a:xfrm>
+      </p:grpSpPr>
+      <p:sp>
+        <p:nvSpPr>
+          <p:cNvPr id="2" name="Slide Image Placeholder 1"/>
+          <p:cNvSpPr>
+            <a:spLocks noGrp="1"/>
+          </p:cNvSpPr>
+          <p:nvPr>
+            <p:ph type="sldImg" idx="2"/>
+          </p:nvPr>
+        </p:nvSpPr>
+        <p:spPr/>
+      </p:sp>
+      <p:sp>
+        <p:nvSpPr>
+          <p:cNvPr id="3" name="Notes Placeholder 2"/>
+          <p:cNvSpPr>
+            <a:spLocks noGrp="1"/>
+          </p:cNvSpPr>
+          <p:nvPr>
+            <p:ph type="body" idx="3" sz="quarter"/>
+          </p:nvPr>
+        </p:nvSpPr>
+        <p:spPr/>
+        <p:txBody>
+          <a:bodyPr/>
+          <a:lstStyle/>
+          <a:p>
+            <a:r>
+              <a:t>Preprilagođavanje i generalizacija</a:t>
+            </a:r>
+          </a:p>
+        </p:txBody>
+      </p:sp>
+      <p:sp>
+        <p:nvSpPr>
+          <p:cNvPr id="4" name="Slide Number Placeholder 3"/>
+          <p:cNvSpPr>
+            <a:spLocks noGrp="1"/>
+          </p:cNvSpPr>
+          <p:nvPr>
+            <p:ph type="sldNum" idx="5" sz="quarter"/>
+          </p:nvPr>
+        </p:nvSpPr>
+        <p:spPr/>
+      </p:sp>
+    </p:spTree>
+  </p:cSld>
+  <p:clrMapOvr>
+    <a:masterClrMapping/>
+  </p:clrMapOvr>
+</p:notes>
+</file>
+
+<file path=ppt/notesSlides/notesSlide18.xml><?xml version="1.0" encoding="utf-8"?>
 <p:notes xmlns:a="http://schemas.openxmlformats.org/drawingml/2006/main" xmlns:p="http://schemas.openxmlformats.org/presentationml/2006/main" xmlns:r="http://schemas.openxmlformats.org/officeDocument/2006/relationships">
   <p:cSld>
     <p:spTree>
@@ -4983,6 +5054,48 @@
       <p:pic>
         <p:nvPicPr>
           <p:cNvPr id="2" name="Picture 1" descr="pptx_17.png"/>
+          <p:cNvPicPr>
+            <a:picLocks noChangeAspect="1"/>
+          </p:cNvPicPr>
+          <p:nvPr/>
+        </p:nvPicPr>
+        <p:blipFill>
+          <a:blip r:embed="rId2"/>
+          <a:stretch>
+            <a:fillRect/>
+          </a:stretch>
+        </p:blipFill>
+        <p:spPr>
+          <a:xfrm>
+            <a:off x="0" y="0"/>
+            <a:ext cx="12191695" cy="6858000"/>
+          </a:xfrm>
+          <a:prstGeom prst="rect">
+            <a:avLst/>
+          </a:prstGeom>
+        </p:spPr>
+      </p:pic>
+    </p:spTree>
+  </p:cSld>
+  <p:clrMapOvr>
+    <a:masterClrMapping/>
+  </p:clrMapOvr>
+</p:sld>
+</file>
+
+<file path=ppt/slides/slide18.xml><?xml version="1.0" encoding="utf-8"?>
+<p:sld xmlns:a="http://schemas.openxmlformats.org/drawingml/2006/main" xmlns:p="http://schemas.openxmlformats.org/presentationml/2006/main" xmlns:r="http://schemas.openxmlformats.org/officeDocument/2006/relationships">
+  <p:cSld>
+    <p:spTree>
+      <p:nvGrpSpPr>
+        <p:cNvPr id="1" name=""/>
+        <p:cNvGrpSpPr/>
+        <p:nvPr/>
+      </p:nvGrpSpPr>
+      <p:grpSpPr/>
+      <p:pic>
+        <p:nvPicPr>
+          <p:cNvPr id="2" name="Picture 1" descr="pptx_18.png"/>
           <p:cNvPicPr>
             <a:picLocks noChangeAspect="1"/>
           </p:cNvPicPr>

</xml_diff>

<commit_message>
Izbacen slajd sa metrikama
</commit_message>
<xml_diff>
--- a/prezentacija.pptx
+++ b/prezentacija.pptx
@@ -22,7 +22,6 @@
     <p:sldId id="270" r:id="rId22"/>
     <p:sldId id="271" r:id="rId23"/>
     <p:sldId id="272" r:id="rId24"/>
-    <p:sldId id="273" r:id="rId25"/>
   </p:sldIdLst>
   <p:sldSz cx="12191695" cy="6858000" type="screen4x3"/>
   <p:notesSz cx="6858000" cy="9144000"/>
@@ -589,7 +588,7 @@
           <a:lstStyle/>
           <a:p>
             <a:r>
-              <a:t>Četiri algoritma nad TF-IDF vektorima</a:t>
+              <a:t>CNN, BiLSTM i hibrid: ista osnova, različita sredina</a:t>
             </a:r>
           </a:p>
         </p:txBody>
@@ -659,7 +658,7 @@
           <a:lstStyle/>
           <a:p>
             <a:r>
-              <a:t>CNN, BiLSTM i hibrid: ista osnova, različita sredina</a:t>
+              <a:t>DistilBERT i MiniLM: šta su i šta smo menjali</a:t>
             </a:r>
           </a:p>
         </p:txBody>
@@ -729,7 +728,7 @@
           <a:lstStyle/>
           <a:p>
             <a:r>
-              <a:t>DistilBERT i MiniLM: šta su i šta smo menjali</a:t>
+              <a:t>Svih trinaest modela na istom test skupu od 9 629 članaka</a:t>
             </a:r>
           </a:p>
         </p:txBody>
@@ -799,7 +798,7 @@
           <a:lstStyle/>
           <a:p>
             <a:r>
-              <a:t>Svih trinaest modela na istom test skupu od 9 629 članaka</a:t>
+              <a:t>Tačnost i složenost modela</a:t>
             </a:r>
           </a:p>
         </p:txBody>
@@ -869,7 +868,7 @@
           <a:lstStyle/>
           <a:p>
             <a:r>
-              <a:t>Tačnost i složenost modela</a:t>
+              <a:t>Preciznost i odziv po modelu</a:t>
             </a:r>
           </a:p>
         </p:txBody>
@@ -939,7 +938,7 @@
           <a:lstStyle/>
           <a:p>
             <a:r>
-              <a:t>Preciznost i odziv po modelu</a:t>
+              <a:t>Kako je koji model treniran i proveren</a:t>
             </a:r>
           </a:p>
         </p:txBody>
@@ -1009,7 +1008,7 @@
           <a:lstStyle/>
           <a:p>
             <a:r>
-              <a:t>Kako je koji model treniran i proveren</a:t>
+              <a:t>Preprilagođavanje i generalizacija</a:t>
             </a:r>
           </a:p>
         </p:txBody>
@@ -1079,76 +1078,6 @@
           <a:lstStyle/>
           <a:p>
             <a:r>
-              <a:t>Preprilagođavanje i generalizacija</a:t>
-            </a:r>
-          </a:p>
-        </p:txBody>
-      </p:sp>
-      <p:sp>
-        <p:nvSpPr>
-          <p:cNvPr id="4" name="Slide Number Placeholder 3"/>
-          <p:cNvSpPr>
-            <a:spLocks noGrp="1"/>
-          </p:cNvSpPr>
-          <p:nvPr>
-            <p:ph type="sldNum" idx="5" sz="quarter"/>
-          </p:nvPr>
-        </p:nvSpPr>
-        <p:spPr/>
-      </p:sp>
-    </p:spTree>
-  </p:cSld>
-  <p:clrMapOvr>
-    <a:masterClrMapping/>
-  </p:clrMapOvr>
-</p:notes>
-</file>
-
-<file path=ppt/notesSlides/notesSlide18.xml><?xml version="1.0" encoding="utf-8"?>
-<p:notes xmlns:a="http://schemas.openxmlformats.org/drawingml/2006/main" xmlns:p="http://schemas.openxmlformats.org/presentationml/2006/main" xmlns:r="http://schemas.openxmlformats.org/officeDocument/2006/relationships">
-  <p:cSld>
-    <p:spTree>
-      <p:nvGrpSpPr>
-        <p:cNvPr id="1" name=""/>
-        <p:cNvGrpSpPr/>
-        <p:nvPr/>
-      </p:nvGrpSpPr>
-      <p:grpSpPr>
-        <a:xfrm>
-          <a:off x="0" y="0"/>
-          <a:ext cx="0" cy="0"/>
-          <a:chOff x="0" y="0"/>
-          <a:chExt cx="0" cy="0"/>
-        </a:xfrm>
-      </p:grpSpPr>
-      <p:sp>
-        <p:nvSpPr>
-          <p:cNvPr id="2" name="Slide Image Placeholder 1"/>
-          <p:cNvSpPr>
-            <a:spLocks noGrp="1"/>
-          </p:cNvSpPr>
-          <p:nvPr>
-            <p:ph type="sldImg" idx="2"/>
-          </p:nvPr>
-        </p:nvSpPr>
-        <p:spPr/>
-      </p:sp>
-      <p:sp>
-        <p:nvSpPr>
-          <p:cNvPr id="3" name="Notes Placeholder 2"/>
-          <p:cNvSpPr>
-            <a:spLocks noGrp="1"/>
-          </p:cNvSpPr>
-          <p:nvPr>
-            <p:ph type="body" idx="3" sz="quarter"/>
-          </p:nvPr>
-        </p:nvSpPr>
-        <p:spPr/>
-        <p:txBody>
-          <a:bodyPr/>
-          <a:lstStyle/>
-          <a:p>
-            <a:r>
               <a:t>Zaključci</a:t>
             </a:r>
           </a:p>
@@ -1709,7 +1638,7 @@
           <a:lstStyle/>
           <a:p>
             <a:r>
-              <a:t>Metrike evaluacije</a:t>
+              <a:t>Četiri algoritma nad TF-IDF vektorima</a:t>
             </a:r>
           </a:p>
         </p:txBody>
@@ -5054,48 +4983,6 @@
       <p:pic>
         <p:nvPicPr>
           <p:cNvPr id="2" name="Picture 1" descr="pptx_17.png"/>
-          <p:cNvPicPr>
-            <a:picLocks noChangeAspect="1"/>
-          </p:cNvPicPr>
-          <p:nvPr/>
-        </p:nvPicPr>
-        <p:blipFill>
-          <a:blip r:embed="rId2"/>
-          <a:stretch>
-            <a:fillRect/>
-          </a:stretch>
-        </p:blipFill>
-        <p:spPr>
-          <a:xfrm>
-            <a:off x="0" y="0"/>
-            <a:ext cx="12191695" cy="6858000"/>
-          </a:xfrm>
-          <a:prstGeom prst="rect">
-            <a:avLst/>
-          </a:prstGeom>
-        </p:spPr>
-      </p:pic>
-    </p:spTree>
-  </p:cSld>
-  <p:clrMapOvr>
-    <a:masterClrMapping/>
-  </p:clrMapOvr>
-</p:sld>
-</file>
-
-<file path=ppt/slides/slide18.xml><?xml version="1.0" encoding="utf-8"?>
-<p:sld xmlns:a="http://schemas.openxmlformats.org/drawingml/2006/main" xmlns:p="http://schemas.openxmlformats.org/presentationml/2006/main" xmlns:r="http://schemas.openxmlformats.org/officeDocument/2006/relationships">
-  <p:cSld>
-    <p:spTree>
-      <p:nvGrpSpPr>
-        <p:cNvPr id="1" name=""/>
-        <p:cNvGrpSpPr/>
-        <p:nvPr/>
-      </p:nvGrpSpPr>
-      <p:grpSpPr/>
-      <p:pic>
-        <p:nvPicPr>
-          <p:cNvPr id="2" name="Picture 1" descr="pptx_18.png"/>
           <p:cNvPicPr>
             <a:picLocks noChangeAspect="1"/>
           </p:cNvPicPr>

</xml_diff>

<commit_message>
Slajd sa sirom pretragom hiperparametara
</commit_message>
<xml_diff>
--- a/prezentacija.pptx
+++ b/prezentacija.pptx
@@ -22,6 +22,7 @@
     <p:sldId id="270" r:id="rId22"/>
     <p:sldId id="271" r:id="rId23"/>
     <p:sldId id="272" r:id="rId24"/>
+    <p:sldId id="273" r:id="rId25"/>
   </p:sldIdLst>
   <p:sldSz cx="12191695" cy="6858000" type="screen4x3"/>
   <p:notesSz cx="6858000" cy="9144000"/>
@@ -588,7 +589,7 @@
           <a:lstStyle/>
           <a:p>
             <a:r>
-              <a:t>CNN, BiLSTM i hibrid: ista osnova, različita sredina</a:t>
+              <a:t>Šira pretraga hiperparametara, logistička regresija</a:t>
             </a:r>
           </a:p>
         </p:txBody>
@@ -658,7 +659,7 @@
           <a:lstStyle/>
           <a:p>
             <a:r>
-              <a:t>DistilBERT i MiniLM: šta su i šta smo menjali</a:t>
+              <a:t>CNN, BiLSTM i hibrid: ista osnova, različita sredina</a:t>
             </a:r>
           </a:p>
         </p:txBody>
@@ -728,7 +729,7 @@
           <a:lstStyle/>
           <a:p>
             <a:r>
-              <a:t>Svih trinaest modela na istom test skupu od 9 629 članaka</a:t>
+              <a:t>DistilBERT i MiniLM: šta su i šta smo menjali</a:t>
             </a:r>
           </a:p>
         </p:txBody>
@@ -798,7 +799,7 @@
           <a:lstStyle/>
           <a:p>
             <a:r>
-              <a:t>Tačnost i složenost modela</a:t>
+              <a:t>Svih trinaest modela na istom test skupu od 9 629 članaka</a:t>
             </a:r>
           </a:p>
         </p:txBody>
@@ -868,7 +869,7 @@
           <a:lstStyle/>
           <a:p>
             <a:r>
-              <a:t>Preciznost i odziv po modelu</a:t>
+              <a:t>Tačnost i složenost modela</a:t>
             </a:r>
           </a:p>
         </p:txBody>
@@ -938,7 +939,7 @@
           <a:lstStyle/>
           <a:p>
             <a:r>
-              <a:t>Kako je koji model treniran i proveren</a:t>
+              <a:t>Preciznost i odziv po modelu</a:t>
             </a:r>
           </a:p>
         </p:txBody>
@@ -1008,7 +1009,7 @@
           <a:lstStyle/>
           <a:p>
             <a:r>
-              <a:t>Preprilagođavanje i generalizacija</a:t>
+              <a:t>Kako je koji model treniran i proveren</a:t>
             </a:r>
           </a:p>
         </p:txBody>
@@ -1034,6 +1035,76 @@
 </file>
 
 <file path=ppt/notesSlides/notesSlide17.xml><?xml version="1.0" encoding="utf-8"?>
+<p:notes xmlns:a="http://schemas.openxmlformats.org/drawingml/2006/main" xmlns:p="http://schemas.openxmlformats.org/presentationml/2006/main" xmlns:r="http://schemas.openxmlformats.org/officeDocument/2006/relationships">
+  <p:cSld>
+    <p:spTree>
+      <p:nvGrpSpPr>
+        <p:cNvPr id="1" name=""/>
+        <p:cNvGrpSpPr/>
+        <p:nvPr/>
+      </p:nvGrpSpPr>
+      <p:grpSpPr>
+        <a:xfrm>
+          <a:off x="0" y="0"/>
+          <a:ext cx="0" cy="0"/>
+          <a:chOff x="0" y="0"/>
+          <a:chExt cx="0" cy="0"/>
+        </a:xfrm>
+      </p:grpSpPr>
+      <p:sp>
+        <p:nvSpPr>
+          <p:cNvPr id="2" name="Slide Image Placeholder 1"/>
+          <p:cNvSpPr>
+            <a:spLocks noGrp="1"/>
+          </p:cNvSpPr>
+          <p:nvPr>
+            <p:ph type="sldImg" idx="2"/>
+          </p:nvPr>
+        </p:nvSpPr>
+        <p:spPr/>
+      </p:sp>
+      <p:sp>
+        <p:nvSpPr>
+          <p:cNvPr id="3" name="Notes Placeholder 2"/>
+          <p:cNvSpPr>
+            <a:spLocks noGrp="1"/>
+          </p:cNvSpPr>
+          <p:nvPr>
+            <p:ph type="body" idx="3" sz="quarter"/>
+          </p:nvPr>
+        </p:nvSpPr>
+        <p:spPr/>
+        <p:txBody>
+          <a:bodyPr/>
+          <a:lstStyle/>
+          <a:p>
+            <a:r>
+              <a:t>Preprilagođavanje i generalizacija</a:t>
+            </a:r>
+          </a:p>
+        </p:txBody>
+      </p:sp>
+      <p:sp>
+        <p:nvSpPr>
+          <p:cNvPr id="4" name="Slide Number Placeholder 3"/>
+          <p:cNvSpPr>
+            <a:spLocks noGrp="1"/>
+          </p:cNvSpPr>
+          <p:nvPr>
+            <p:ph type="sldNum" idx="5" sz="quarter"/>
+          </p:nvPr>
+        </p:nvSpPr>
+        <p:spPr/>
+      </p:sp>
+    </p:spTree>
+  </p:cSld>
+  <p:clrMapOvr>
+    <a:masterClrMapping/>
+  </p:clrMapOvr>
+</p:notes>
+</file>
+
+<file path=ppt/notesSlides/notesSlide18.xml><?xml version="1.0" encoding="utf-8"?>
 <p:notes xmlns:a="http://schemas.openxmlformats.org/drawingml/2006/main" xmlns:p="http://schemas.openxmlformats.org/presentationml/2006/main" xmlns:r="http://schemas.openxmlformats.org/officeDocument/2006/relationships">
   <p:cSld>
     <p:spTree>
@@ -4983,6 +5054,48 @@
       <p:pic>
         <p:nvPicPr>
           <p:cNvPr id="2" name="Picture 1" descr="pptx_17.png"/>
+          <p:cNvPicPr>
+            <a:picLocks noChangeAspect="1"/>
+          </p:cNvPicPr>
+          <p:nvPr/>
+        </p:nvPicPr>
+        <p:blipFill>
+          <a:blip r:embed="rId2"/>
+          <a:stretch>
+            <a:fillRect/>
+          </a:stretch>
+        </p:blipFill>
+        <p:spPr>
+          <a:xfrm>
+            <a:off x="0" y="0"/>
+            <a:ext cx="12191695" cy="6858000"/>
+          </a:xfrm>
+          <a:prstGeom prst="rect">
+            <a:avLst/>
+          </a:prstGeom>
+        </p:spPr>
+      </p:pic>
+    </p:spTree>
+  </p:cSld>
+  <p:clrMapOvr>
+    <a:masterClrMapping/>
+  </p:clrMapOvr>
+</p:sld>
+</file>
+
+<file path=ppt/slides/slide18.xml><?xml version="1.0" encoding="utf-8"?>
+<p:sld xmlns:a="http://schemas.openxmlformats.org/drawingml/2006/main" xmlns:p="http://schemas.openxmlformats.org/presentationml/2006/main" xmlns:r="http://schemas.openxmlformats.org/officeDocument/2006/relationships">
+  <p:cSld>
+    <p:spTree>
+      <p:nvGrpSpPr>
+        <p:cNvPr id="1" name=""/>
+        <p:cNvGrpSpPr/>
+        <p:nvPr/>
+      </p:nvGrpSpPr>
+      <p:grpSpPr/>
+      <p:pic>
+        <p:nvPicPr>
+          <p:cNvPr id="2" name="Picture 1" descr="pptx_18.png"/>
           <p:cNvPicPr>
             <a:picLocks noChangeAspect="1"/>
           </p:cNvPicPr>

</xml_diff>